<commit_message>
Update detailed document and deck with verified hardening-pass metrics (Q01 1.00, overall 0.83/0.81 @12, 0.70/0.76 @5)
</commit_message>
<xml_diff>
--- a/Industrial_Knowledge_Intelligence_Deck.pptx
+++ b/Industrial_Knowledge_Intelligence_Deck.pptx
@@ -15,9 +15,10 @@
     <p:sldId id="263" r:id="rId9"/>
     <p:sldId id="264" r:id="rId10"/>
     <p:sldId id="265" r:id="rId11"/>
+    <p:sldId id="266" r:id="rId12"/>
   </p:sldIdLst>
   <p:notesMasterIdLst>
-    <p:notesMasterId r:id="rId12"/>
+    <p:notesMasterId r:id="rId13"/>
   </p:notesMasterIdLst>
   <p:sldSz cx="12192000" cy="6858000"/>
   <p:notesSz cx="6858000" cy="12192000"/>
@@ -623,6 +624,94 @@
             <a:fld id="{F7021451-1387-4CA6-816F-3879F97B5CBC}" type="slidenum">
               <a:rPr lang="en-US"/>
               <a:t>10</a:t>
+            </a:fld>
+            <a:endParaRPr lang="en-US"/>
+          </a:p>
+        </p:txBody>
+      </p:sp>
+    </p:spTree>
+    <p:extLst>
+      <p:ext uri="{BB962C8B-B14F-4D97-AF65-F5344CB8AC3E}">
+        <p14:creationId xmlns:p14="http://schemas.microsoft.com/office/powerpoint/2010/main" val="1024086991"/>
+      </p:ext>
+    </p:extLst>
+  </p:cSld>
+  <p:clrMapOvr>
+    <a:masterClrMapping/>
+  </p:clrMapOvr>
+</p:notes>
+</file>
+
+<file path=ppt/notesSlides/notesSlide11.xml><?xml version="1.0" encoding="utf-8"?>
+<p:notes xmlns:a="http://schemas.openxmlformats.org/drawingml/2006/main" xmlns:r="http://schemas.openxmlformats.org/officeDocument/2006/relationships" xmlns:p="http://schemas.openxmlformats.org/presentationml/2006/main">
+  <p:cSld>
+    <p:spTree>
+      <p:nvGrpSpPr>
+        <p:cNvPr id="1" name=""/>
+        <p:cNvGrpSpPr/>
+        <p:nvPr/>
+      </p:nvGrpSpPr>
+      <p:grpSpPr>
+        <a:xfrm>
+          <a:off x="0" y="0"/>
+          <a:ext cx="0" cy="0"/>
+          <a:chOff x="0" y="0"/>
+          <a:chExt cx="0" cy="0"/>
+        </a:xfrm>
+      </p:grpSpPr>
+      <p:sp>
+        <p:nvSpPr>
+          <p:cNvPr id="2" name="Slide Image Placeholder 1"/>
+          <p:cNvSpPr>
+            <a:spLocks noGrp="1" noRot="1" noChangeAspect="1"/>
+          </p:cNvSpPr>
+          <p:nvPr>
+            <p:ph type="sldImg"/>
+          </p:nvPr>
+        </p:nvSpPr>
+        <p:spPr/>
+      </p:sp>
+      <p:sp>
+        <p:nvSpPr>
+          <p:cNvPr id="3" name="Notes Placeholder 2"/>
+          <p:cNvSpPr>
+            <a:spLocks noGrp="1"/>
+          </p:cNvSpPr>
+          <p:nvPr>
+            <p:ph type="body" idx="1"/>
+          </p:nvPr>
+        </p:nvSpPr>
+        <p:spPr/>
+        <p:txBody>
+          <a:bodyPr/>
+          <a:lstStyle/>
+          <a:p>
+            <a:r>
+              <a:rPr lang="en-US" dirty="0"/>
+              <a:t/>
+            </a:r>
+            <a:endParaRPr lang="en-US" dirty="0"/>
+          </a:p>
+        </p:txBody>
+      </p:sp>
+      <p:sp>
+        <p:nvSpPr>
+          <p:cNvPr id="4" name="Slide Number Placeholder 3"/>
+          <p:cNvSpPr>
+            <a:spLocks noGrp="1"/>
+          </p:cNvSpPr>
+          <p:nvPr>
+            <p:ph type="sldNum" sz="quarter" idx="10"/>
+          </p:nvPr>
+        </p:nvSpPr>
+        <p:spPr/>
+        <p:txBody>
+          <a:bodyPr/>
+          <a:lstStyle/>
+          <a:p>
+            <a:fld id="{F7021451-1387-4CA6-816F-3879F97B5CBC}" type="slidenum">
+              <a:rPr lang="en-US"/>
+              <a:t>11</a:t>
             </a:fld>
             <a:endParaRPr lang="en-US"/>
           </a:p>
@@ -1684,7 +1773,7 @@
         </p:nvSpPr>
         <p:spPr>
           <a:xfrm>
-            <a:off x="822960" y="2103120"/>
+            <a:off x="822960" y="1920240"/>
             <a:ext cx="10515600" cy="1005840"/>
           </a:xfrm>
           <a:prstGeom prst="rect">
@@ -1723,7 +1812,7 @@
         </p:nvSpPr>
         <p:spPr>
           <a:xfrm>
-            <a:off x="822960" y="3200400"/>
+            <a:off x="822960" y="3017520"/>
             <a:ext cx="10058400" cy="822960"/>
           </a:xfrm>
           <a:prstGeom prst="rect">
@@ -1779,7 +1868,7 @@
               <a:buNone/>
             </a:pPr>
             <a:r>
-              <a:rPr lang="en-US" sz="1500" b="1" dirty="0">
+              <a:rPr lang="en-US" sz="1500" dirty="0">
                 <a:solidFill>
                   <a:srgbClr val="9BB4E0"/>
                 </a:solidFill>
@@ -1787,21 +1876,7 @@
                 <a:ea typeface="Calibri" pitchFamily="34" charset="-122"/>
                 <a:cs typeface="Calibri" pitchFamily="34" charset="-120"/>
               </a:rPr>
-              <a:t>ET AI Hackathon 2.0</a:t>
-            </a:r>
-            <a:pPr indent="0" marL="0">
-              <a:buNone/>
-            </a:pPr>
-            <a:r>
-              <a:rPr lang="en-US" sz="1500" dirty="0">
-                <a:solidFill>
-                  <a:srgbClr val="9BB4E0"/>
-                </a:solidFill>
-                <a:latin typeface="Calibri" pitchFamily="34" charset="0"/>
-                <a:ea typeface="Calibri" pitchFamily="34" charset="-122"/>
-                <a:cs typeface="Calibri" pitchFamily="34" charset="-120"/>
-              </a:rPr>
-              <a:t>   ·   Round 2 Build Sprint   ·   Problem Statement #8</a:t>
+              <a:t>ET AI Hackathon 2.0   ·   Round 2 — Revised Submission   ·   Problem Statement #8</a:t>
             </a:r>
             <a:endParaRPr lang="en-US" sz="1500" dirty="0"/>
           </a:p>
@@ -1818,6 +1893,455 @@
 <file path=ppt/slides/slide10.xml><?xml version="1.0" encoding="utf-8"?>
 <p:sld xmlns:a="http://schemas.openxmlformats.org/drawingml/2006/main" xmlns:r="http://schemas.openxmlformats.org/officeDocument/2006/relationships" xmlns:p="http://schemas.openxmlformats.org/presentationml/2006/main">
   <p:cSld name="Slide 10">
+    <p:bg>
+      <p:bgPr>
+        <a:solidFill>
+          <a:srgbClr val="FFFFFF"/>
+        </a:solidFill>
+      </p:bgPr>
+    </p:bg>
+    <p:spTree>
+      <p:nvGrpSpPr>
+        <p:cNvPr id="1" name=""/>
+        <p:cNvGrpSpPr/>
+        <p:nvPr/>
+      </p:nvGrpSpPr>
+      <p:grpSpPr>
+        <a:xfrm>
+          <a:off x="0" y="0"/>
+          <a:ext cx="0" cy="0"/>
+          <a:chOff x="0" y="0"/>
+          <a:chExt cx="0" cy="0"/>
+        </a:xfrm>
+      </p:grpSpPr>
+      <p:sp>
+        <p:nvSpPr>
+          <p:cNvPr id="2" name="Text 0"/>
+          <p:cNvSpPr/>
+          <p:nvPr/>
+        </p:nvSpPr>
+        <p:spPr>
+          <a:xfrm>
+            <a:off x="457200" y="365760"/>
+            <a:ext cx="11247120" cy="640080"/>
+          </a:xfrm>
+          <a:prstGeom prst="rect">
+            <a:avLst/>
+          </a:prstGeom>
+          <a:noFill/>
+          <a:ln/>
+        </p:spPr>
+        <p:txBody>
+          <a:bodyPr wrap="square" rtlCol="0" anchor="ctr"/>
+          <a:lstStyle/>
+          <a:p>
+            <a:pPr indent="0" marL="0">
+              <a:buNone/>
+            </a:pPr>
+            <a:r>
+              <a:rPr lang="en-US" sz="3200" b="1" dirty="0">
+                <a:solidFill>
+                  <a:srgbClr val="1F3864"/>
+                </a:solidFill>
+                <a:latin typeface="Cambria" pitchFamily="34" charset="0"/>
+                <a:ea typeface="Cambria" pitchFamily="34" charset="-122"/>
+                <a:cs typeface="Cambria" pitchFamily="34" charset="-120"/>
+              </a:rPr>
+              <a:t>Known limitations — documented, not hidden</a:t>
+            </a:r>
+            <a:endParaRPr lang="en-US" sz="3200" dirty="0"/>
+          </a:p>
+        </p:txBody>
+      </p:sp>
+      <p:sp>
+        <p:nvSpPr>
+          <p:cNvPr id="3" name="Text 1"/>
+          <p:cNvSpPr/>
+          <p:nvPr/>
+        </p:nvSpPr>
+        <p:spPr>
+          <a:xfrm>
+            <a:off x="457200" y="1051560"/>
+            <a:ext cx="11247120" cy="548640"/>
+          </a:xfrm>
+          <a:prstGeom prst="rect">
+            <a:avLst/>
+          </a:prstGeom>
+          <a:noFill/>
+          <a:ln/>
+        </p:spPr>
+        <p:txBody>
+          <a:bodyPr wrap="square" rtlCol="0" anchor="ctr"/>
+          <a:lstStyle/>
+          <a:p>
+            <a:pPr indent="0" marL="0">
+              <a:buNone/>
+            </a:pPr>
+            <a:r>
+              <a:rPr lang="en-US" sz="1500" i="1" dirty="0">
+                <a:solidFill>
+                  <a:srgbClr val="1A1A1A"/>
+                </a:solidFill>
+                <a:latin typeface="Calibri" pitchFamily="34" charset="0"/>
+                <a:ea typeface="Calibri" pitchFamily="34" charset="-122"/>
+                <a:cs typeface="Calibri" pitchFamily="34" charset="-120"/>
+              </a:rPr>
+              <a:t>Understanding failure modes precisely is more valuable than pretending they don't exist.</a:t>
+            </a:r>
+            <a:endParaRPr lang="en-US" sz="1500" dirty="0"/>
+          </a:p>
+        </p:txBody>
+      </p:sp>
+      <p:sp>
+        <p:nvSpPr>
+          <p:cNvPr id="4" name="Shape 2"/>
+          <p:cNvSpPr/>
+          <p:nvPr/>
+        </p:nvSpPr>
+        <p:spPr>
+          <a:xfrm>
+            <a:off x="457200" y="1783080"/>
+            <a:ext cx="11247120" cy="1234440"/>
+          </a:xfrm>
+          <a:prstGeom prst="roundRect">
+            <a:avLst>
+              <a:gd name="adj" fmla="val 5926"/>
+            </a:avLst>
+          </a:prstGeom>
+          <a:solidFill>
+            <a:srgbClr val="F4F6F9"/>
+          </a:solidFill>
+          <a:ln/>
+        </p:spPr>
+      </p:sp>
+      <p:sp>
+        <p:nvSpPr>
+          <p:cNvPr id="5" name="Text 3"/>
+          <p:cNvSpPr/>
+          <p:nvPr/>
+        </p:nvSpPr>
+        <p:spPr>
+          <a:xfrm>
+            <a:off x="731520" y="1947672"/>
+            <a:ext cx="10698480" cy="411480"/>
+          </a:xfrm>
+          <a:prstGeom prst="rect">
+            <a:avLst/>
+          </a:prstGeom>
+          <a:noFill/>
+          <a:ln/>
+        </p:spPr>
+        <p:txBody>
+          <a:bodyPr wrap="square" rtlCol="0" anchor="ctr"/>
+          <a:lstStyle/>
+          <a:p>
+            <a:pPr indent="0" marL="0">
+              <a:buNone/>
+            </a:pPr>
+            <a:r>
+              <a:rPr lang="en-US" sz="1700" b="1" dirty="0">
+                <a:solidFill>
+                  <a:srgbClr val="993C1D"/>
+                </a:solidFill>
+                <a:latin typeface="Calibri" pitchFamily="34" charset="0"/>
+                <a:ea typeface="Calibri" pitchFamily="34" charset="-122"/>
+                <a:cs typeface="Calibri" pitchFamily="34" charset="-120"/>
+              </a:rPr>
+              <a:t>Hop-tier tie-flooding (Q02)</a:t>
+            </a:r>
+            <a:endParaRPr lang="en-US" sz="1700" dirty="0"/>
+          </a:p>
+        </p:txBody>
+      </p:sp>
+      <p:sp>
+        <p:nvSpPr>
+          <p:cNvPr id="6" name="Text 4"/>
+          <p:cNvSpPr/>
+          <p:nvPr/>
+        </p:nvSpPr>
+        <p:spPr>
+          <a:xfrm>
+            <a:off x="731520" y="2331720"/>
+            <a:ext cx="10698480" cy="594360"/>
+          </a:xfrm>
+          <a:prstGeom prst="rect">
+            <a:avLst/>
+          </a:prstGeom>
+          <a:noFill/>
+          <a:ln/>
+        </p:spPr>
+        <p:txBody>
+          <a:bodyPr wrap="square" rtlCol="0" anchor="ctr"/>
+          <a:lstStyle/>
+          <a:p>
+            <a:pPr indent="0" marL="0">
+              <a:buNone/>
+            </a:pPr>
+            <a:r>
+              <a:rPr lang="en-US" sz="1300" dirty="0">
+                <a:solidFill>
+                  <a:srgbClr val="1A1A1A"/>
+                </a:solidFill>
+                <a:latin typeface="Calibri" pitchFamily="34" charset="0"/>
+                <a:ea typeface="Calibri" pitchFamily="34" charset="-122"/>
+                <a:cs typeface="Calibri" pitchFamily="34" charset="-120"/>
+              </a:rPr>
+              <a:t>Many documents share an identical graph score for merely mentioning the query entity, crowding out a more specific but structurally-further answer. Two fixes attempted, precisely diagnosed, neither solved it — a genuine ranking ceiling, not an unbuilt fix.</a:t>
+            </a:r>
+            <a:endParaRPr lang="en-US" sz="1300" dirty="0"/>
+          </a:p>
+        </p:txBody>
+      </p:sp>
+      <p:sp>
+        <p:nvSpPr>
+          <p:cNvPr id="7" name="Shape 5"/>
+          <p:cNvSpPr/>
+          <p:nvPr/>
+        </p:nvSpPr>
+        <p:spPr>
+          <a:xfrm>
+            <a:off x="457200" y="3200400"/>
+            <a:ext cx="11247120" cy="1234440"/>
+          </a:xfrm>
+          <a:prstGeom prst="roundRect">
+            <a:avLst>
+              <a:gd name="adj" fmla="val 5926"/>
+            </a:avLst>
+          </a:prstGeom>
+          <a:solidFill>
+            <a:srgbClr val="F4F6F9"/>
+          </a:solidFill>
+          <a:ln/>
+        </p:spPr>
+      </p:sp>
+      <p:sp>
+        <p:nvSpPr>
+          <p:cNvPr id="8" name="Text 6"/>
+          <p:cNvSpPr/>
+          <p:nvPr/>
+        </p:nvSpPr>
+        <p:spPr>
+          <a:xfrm>
+            <a:off x="731520" y="3364992"/>
+            <a:ext cx="10698480" cy="411480"/>
+          </a:xfrm>
+          <a:prstGeom prst="rect">
+            <a:avLst/>
+          </a:prstGeom>
+          <a:noFill/>
+          <a:ln/>
+        </p:spPr>
+        <p:txBody>
+          <a:bodyPr wrap="square" rtlCol="0" anchor="ctr"/>
+          <a:lstStyle/>
+          <a:p>
+            <a:pPr indent="0" marL="0">
+              <a:buNone/>
+            </a:pPr>
+            <a:r>
+              <a:rPr lang="en-US" sz="1700" b="1" dirty="0">
+                <a:solidFill>
+                  <a:srgbClr val="993C1D"/>
+                </a:solidFill>
+                <a:latin typeface="Calibri" pitchFamily="34" charset="0"/>
+                <a:ea typeface="Calibri" pitchFamily="34" charset="-122"/>
+                <a:cs typeface="Calibri" pitchFamily="34" charset="-120"/>
+              </a:rPr>
+              <a:t>Aggregate margin at strict cutoffs</a:t>
+            </a:r>
+            <a:endParaRPr lang="en-US" sz="1700" dirty="0"/>
+          </a:p>
+        </p:txBody>
+      </p:sp>
+      <p:sp>
+        <p:nvSpPr>
+          <p:cNvPr id="9" name="Text 7"/>
+          <p:cNvSpPr/>
+          <p:nvPr/>
+        </p:nvSpPr>
+        <p:spPr>
+          <a:xfrm>
+            <a:off x="731520" y="3749040"/>
+            <a:ext cx="10698480" cy="594360"/>
+          </a:xfrm>
+          <a:prstGeom prst="rect">
+            <a:avLst/>
+          </a:prstGeom>
+          <a:noFill/>
+          <a:ln/>
+        </p:spPr>
+        <p:txBody>
+          <a:bodyPr wrap="square" rtlCol="0" anchor="ctr"/>
+          <a:lstStyle/>
+          <a:p>
+            <a:pPr indent="0" marL="0">
+              <a:buNone/>
+            </a:pPr>
+            <a:r>
+              <a:rPr lang="en-US" sz="1300" dirty="0">
+                <a:solidFill>
+                  <a:srgbClr val="1A1A1A"/>
+                </a:solidFill>
+                <a:latin typeface="Calibri" pitchFamily="34" charset="0"/>
+                <a:ea typeface="Calibri" pitchFamily="34" charset="-122"/>
+                <a:cs typeface="Calibri" pitchFamily="34" charset="-120"/>
+              </a:rPr>
+              <a:t>At top-5, hybrid trails vector-only (0.70 vs 0.76) due to hop-0 graph noise on single-document questions. The system's advantage concentrates on multi-hop questions, not every question type — stated directly.</a:t>
+            </a:r>
+            <a:endParaRPr lang="en-US" sz="1300" dirty="0"/>
+          </a:p>
+        </p:txBody>
+      </p:sp>
+      <p:sp>
+        <p:nvSpPr>
+          <p:cNvPr id="10" name="Shape 8"/>
+          <p:cNvSpPr/>
+          <p:nvPr/>
+        </p:nvSpPr>
+        <p:spPr>
+          <a:xfrm>
+            <a:off x="457200" y="4709160"/>
+            <a:ext cx="11247120" cy="914400"/>
+          </a:xfrm>
+          <a:prstGeom prst="roundRect">
+            <a:avLst>
+              <a:gd name="adj" fmla="val 8000"/>
+            </a:avLst>
+          </a:prstGeom>
+          <a:solidFill>
+            <a:srgbClr val="E1F5EE"/>
+          </a:solidFill>
+          <a:ln/>
+        </p:spPr>
+      </p:sp>
+      <p:sp>
+        <p:nvSpPr>
+          <p:cNvPr id="11" name="Text 9"/>
+          <p:cNvSpPr/>
+          <p:nvPr/>
+        </p:nvSpPr>
+        <p:spPr>
+          <a:xfrm>
+            <a:off x="731520" y="4709160"/>
+            <a:ext cx="10698480" cy="914400"/>
+          </a:xfrm>
+          <a:prstGeom prst="rect">
+            <a:avLst/>
+          </a:prstGeom>
+          <a:noFill/>
+          <a:ln/>
+        </p:spPr>
+        <p:txBody>
+          <a:bodyPr wrap="square" rtlCol="0" anchor="ctr"/>
+          <a:lstStyle/>
+          <a:p>
+            <a:pPr indent="0" marL="0">
+              <a:buNone/>
+            </a:pPr>
+            <a:r>
+              <a:rPr lang="en-US" sz="1400" b="1" dirty="0">
+                <a:solidFill>
+                  <a:srgbClr val="0F6E56"/>
+                </a:solidFill>
+                <a:latin typeface="Calibri" pitchFamily="34" charset="0"/>
+                <a:ea typeface="Calibri" pitchFamily="34" charset="-122"/>
+                <a:cs typeface="Calibri" pitchFamily="34" charset="-120"/>
+              </a:rPr>
+              <a:t>Both are understood and reproducible. The full pipeline, including the honest cases, can be cloned and re-verified by anyone.</a:t>
+            </a:r>
+            <a:endParaRPr lang="en-US" sz="1400" dirty="0"/>
+          </a:p>
+        </p:txBody>
+      </p:sp>
+      <p:sp>
+        <p:nvSpPr>
+          <p:cNvPr id="12" name="Text 10"/>
+          <p:cNvSpPr/>
+          <p:nvPr/>
+        </p:nvSpPr>
+        <p:spPr>
+          <a:xfrm>
+            <a:off x="457200" y="6446520"/>
+            <a:ext cx="9601200" cy="274320"/>
+          </a:xfrm>
+          <a:prstGeom prst="rect">
+            <a:avLst/>
+          </a:prstGeom>
+          <a:noFill/>
+          <a:ln/>
+        </p:spPr>
+        <p:txBody>
+          <a:bodyPr wrap="square" rtlCol="0" anchor="ctr"/>
+          <a:lstStyle/>
+          <a:p>
+            <a:pPr algn="l" indent="0" marL="0">
+              <a:buNone/>
+            </a:pPr>
+            <a:r>
+              <a:rPr lang="en-US" sz="900" dirty="0">
+                <a:solidFill>
+                  <a:srgbClr val="6B6B68"/>
+                </a:solidFill>
+                <a:latin typeface="Calibri" pitchFamily="34" charset="0"/>
+                <a:ea typeface="Calibri" pitchFamily="34" charset="-122"/>
+                <a:cs typeface="Calibri" pitchFamily="34" charset="-120"/>
+              </a:rPr>
+              <a:t>ET AI Hackathon 2.0  ·  Problem #8  ·  Industrial Knowledge Intelligence (Revised)</a:t>
+            </a:r>
+            <a:endParaRPr lang="en-US" sz="900" dirty="0"/>
+          </a:p>
+        </p:txBody>
+      </p:sp>
+      <p:sp>
+        <p:nvSpPr>
+          <p:cNvPr id="13" name="Text 11"/>
+          <p:cNvSpPr/>
+          <p:nvPr/>
+        </p:nvSpPr>
+        <p:spPr>
+          <a:xfrm>
+            <a:off x="11247120" y="6446520"/>
+            <a:ext cx="457200" cy="274320"/>
+          </a:xfrm>
+          <a:prstGeom prst="rect">
+            <a:avLst/>
+          </a:prstGeom>
+          <a:noFill/>
+          <a:ln/>
+        </p:spPr>
+        <p:txBody>
+          <a:bodyPr wrap="square" rtlCol="0" anchor="ctr"/>
+          <a:lstStyle/>
+          <a:p>
+            <a:pPr algn="r" indent="0" marL="0">
+              <a:buNone/>
+            </a:pPr>
+            <a:r>
+              <a:rPr lang="en-US" sz="900" dirty="0">
+                <a:solidFill>
+                  <a:srgbClr val="6B6B68"/>
+                </a:solidFill>
+                <a:latin typeface="Calibri" pitchFamily="34" charset="0"/>
+                <a:ea typeface="Calibri" pitchFamily="34" charset="-122"/>
+                <a:cs typeface="Calibri" pitchFamily="34" charset="-120"/>
+              </a:rPr>
+              <a:t>10</a:t>
+            </a:r>
+            <a:endParaRPr lang="en-US" sz="900" dirty="0"/>
+          </a:p>
+        </p:txBody>
+      </p:sp>
+    </p:spTree>
+  </p:cSld>
+  <p:clrMapOvr>
+    <a:masterClrMapping/>
+  </p:clrMapOvr>
+</p:sld>
+</file>
+
+<file path=ppt/slides/slide11.xml><?xml version="1.0" encoding="utf-8"?>
+<p:sld xmlns:a="http://schemas.openxmlformats.org/drawingml/2006/main" xmlns:r="http://schemas.openxmlformats.org/officeDocument/2006/relationships" xmlns:p="http://schemas.openxmlformats.org/presentationml/2006/main">
+  <p:cSld name="Slide 11">
     <p:bg>
       <p:bgPr>
         <a:solidFill>
@@ -1926,7 +2450,7 @@
         <p:spPr>
           <a:xfrm>
             <a:off x="548640" y="1783080"/>
-            <a:ext cx="5486400" cy="502920"/>
+            <a:ext cx="5486400" cy="457200"/>
           </a:xfrm>
           <a:prstGeom prst="rect">
             <a:avLst/>
@@ -1943,7 +2467,7 @@
               <a:buChar char="•"/>
             </a:pPr>
             <a:r>
-              <a:rPr lang="en-US" sz="1400" dirty="0">
+              <a:rPr lang="en-US" sz="1350" dirty="0">
                 <a:solidFill>
                   <a:srgbClr val="FFFFFF"/>
                 </a:solidFill>
@@ -1953,7 +2477,7 @@
               </a:rPr>
               <a:t>In-memory graph → managed graph database</a:t>
             </a:r>
-            <a:endParaRPr lang="en-US" sz="1400" dirty="0"/>
+            <a:endParaRPr lang="en-US" sz="1350" dirty="0"/>
           </a:p>
         </p:txBody>
       </p:sp>
@@ -1965,8 +2489,8 @@
         </p:nvSpPr>
         <p:spPr>
           <a:xfrm>
-            <a:off x="548640" y="2350008"/>
-            <a:ext cx="5486400" cy="502920"/>
+            <a:off x="548640" y="2286000"/>
+            <a:ext cx="5486400" cy="457200"/>
           </a:xfrm>
           <a:prstGeom prst="rect">
             <a:avLst/>
@@ -1983,7 +2507,7 @@
               <a:buChar char="•"/>
             </a:pPr>
             <a:r>
-              <a:rPr lang="en-US" sz="1400" dirty="0">
+              <a:rPr lang="en-US" sz="1350" dirty="0">
                 <a:solidFill>
                   <a:srgbClr val="FFFFFF"/>
                 </a:solidFill>
@@ -1993,7 +2517,7 @@
               </a:rPr>
               <a:t>Local vector store → managed vector service</a:t>
             </a:r>
-            <a:endParaRPr lang="en-US" sz="1400" dirty="0"/>
+            <a:endParaRPr lang="en-US" sz="1350" dirty="0"/>
           </a:p>
         </p:txBody>
       </p:sp>
@@ -2005,8 +2529,8 @@
         </p:nvSpPr>
         <p:spPr>
           <a:xfrm>
-            <a:off x="548640" y="2916936"/>
-            <a:ext cx="5486400" cy="502920"/>
+            <a:off x="548640" y="2788920"/>
+            <a:ext cx="5486400" cy="457200"/>
           </a:xfrm>
           <a:prstGeom prst="rect">
             <a:avLst/>
@@ -2023,7 +2547,7 @@
               <a:buChar char="•"/>
             </a:pPr>
             <a:r>
-              <a:rPr lang="en-US" sz="1400" dirty="0">
+              <a:rPr lang="en-US" sz="1350" dirty="0">
                 <a:solidFill>
                   <a:srgbClr val="FFFFFF"/>
                 </a:solidFill>
@@ -2031,9 +2555,9 @@
                 <a:ea typeface="Calibri" pitchFamily="34" charset="-122"/>
                 <a:cs typeface="Calibri" pitchFamily="34" charset="-120"/>
               </a:rPr>
-              <a:t>Extraction cached per document — unchanged corpus costs zero API calls</a:t>
-            </a:r>
-            <a:endParaRPr lang="en-US" sz="1400" dirty="0"/>
+              <a:t>Extraction cached per document — zero-cost re-runs</a:t>
+            </a:r>
+            <a:endParaRPr lang="en-US" sz="1350" dirty="0"/>
           </a:p>
         </p:txBody>
       </p:sp>
@@ -2045,8 +2569,8 @@
         </p:nvSpPr>
         <p:spPr>
           <a:xfrm>
-            <a:off x="548640" y="3483864"/>
-            <a:ext cx="5486400" cy="502920"/>
+            <a:off x="548640" y="3291840"/>
+            <a:ext cx="5486400" cy="457200"/>
           </a:xfrm>
           <a:prstGeom prst="rect">
             <a:avLst/>
@@ -2063,7 +2587,7 @@
               <a:buChar char="•"/>
             </a:pPr>
             <a:r>
-              <a:rPr lang="en-US" sz="1400" dirty="0">
+              <a:rPr lang="en-US" sz="1350" dirty="0">
                 <a:solidFill>
                   <a:srgbClr val="FFFFFF"/>
                 </a:solidFill>
@@ -2071,9 +2595,9 @@
                 <a:ea typeface="Calibri" pitchFamily="34" charset="-122"/>
                 <a:cs typeface="Calibri" pitchFamily="34" charset="-120"/>
               </a:rPr>
-              <a:t>Each stage modular — swap one layer without touching the rest</a:t>
-            </a:r>
-            <a:endParaRPr lang="en-US" sz="1400" dirty="0"/>
+              <a:t>CI + 26-test suite runs on every push</a:t>
+            </a:r>
+            <a:endParaRPr lang="en-US" sz="1350" dirty="0"/>
           </a:p>
         </p:txBody>
       </p:sp>
@@ -2085,47 +2609,8 @@
         </p:nvSpPr>
         <p:spPr>
           <a:xfrm>
-            <a:off x="6309360" y="1371600"/>
-            <a:ext cx="5394960" cy="365760"/>
-          </a:xfrm>
-          <a:prstGeom prst="rect">
-            <a:avLst/>
-          </a:prstGeom>
-          <a:noFill/>
-          <a:ln/>
-        </p:spPr>
-        <p:txBody>
-          <a:bodyPr wrap="square" rtlCol="0" anchor="ctr"/>
-          <a:lstStyle/>
-          <a:p>
-            <a:pPr indent="0" marL="0">
-              <a:buNone/>
-            </a:pPr>
-            <a:r>
-              <a:rPr lang="en-US" sz="1300" b="1" spc="100" kern="0" dirty="0">
-                <a:solidFill>
-                  <a:srgbClr val="8BC5AE"/>
-                </a:solidFill>
-                <a:latin typeface="Calibri" pitchFamily="34" charset="0"/>
-                <a:ea typeface="Calibri" pitchFamily="34" charset="-122"/>
-                <a:cs typeface="Calibri" pitchFamily="34" charset="-120"/>
-              </a:rPr>
-              <a:t>PHASE 2 COMPONENTS</a:t>
-            </a:r>
-            <a:endParaRPr lang="en-US" sz="1300" dirty="0"/>
-          </a:p>
-        </p:txBody>
-      </p:sp>
-      <p:sp>
-        <p:nvSpPr>
-          <p:cNvPr id="9" name="Text 7"/>
-          <p:cNvSpPr/>
-          <p:nvPr/>
-        </p:nvSpPr>
-        <p:spPr>
-          <a:xfrm>
-            <a:off x="6309360" y="1783080"/>
-            <a:ext cx="5394960" cy="685800"/>
+            <a:off x="548640" y="3794760"/>
+            <a:ext cx="5486400" cy="457200"/>
           </a:xfrm>
           <a:prstGeom prst="rect">
             <a:avLst/>
@@ -2142,7 +2627,7 @@
               <a:buChar char="•"/>
             </a:pPr>
             <a:r>
-              <a:rPr lang="en-US" sz="1400" dirty="0">
+              <a:rPr lang="en-US" sz="1350" dirty="0">
                 <a:solidFill>
                   <a:srgbClr val="FFFFFF"/>
                 </a:solidFill>
@@ -2150,9 +2635,48 @@
                 <a:ea typeface="Calibri" pitchFamily="34" charset="-122"/>
                 <a:cs typeface="Calibri" pitchFamily="34" charset="-120"/>
               </a:rPr>
-              <a:t>Maintenance &amp; root-cause agent — failure history into predictive recommendations</a:t>
-            </a:r>
-            <a:endParaRPr lang="en-US" sz="1400" dirty="0"/>
+              <a:t>Docker packaging included (build unverified)</a:t>
+            </a:r>
+            <a:endParaRPr lang="en-US" sz="1350" dirty="0"/>
+          </a:p>
+        </p:txBody>
+      </p:sp>
+      <p:sp>
+        <p:nvSpPr>
+          <p:cNvPr id="9" name="Text 7"/>
+          <p:cNvSpPr/>
+          <p:nvPr/>
+        </p:nvSpPr>
+        <p:spPr>
+          <a:xfrm>
+            <a:off x="6309360" y="1371600"/>
+            <a:ext cx="5394960" cy="365760"/>
+          </a:xfrm>
+          <a:prstGeom prst="rect">
+            <a:avLst/>
+          </a:prstGeom>
+          <a:noFill/>
+          <a:ln/>
+        </p:spPr>
+        <p:txBody>
+          <a:bodyPr wrap="square" rtlCol="0" anchor="ctr"/>
+          <a:lstStyle/>
+          <a:p>
+            <a:pPr indent="0" marL="0">
+              <a:buNone/>
+            </a:pPr>
+            <a:r>
+              <a:rPr lang="en-US" sz="1300" b="1" spc="100" kern="0" dirty="0">
+                <a:solidFill>
+                  <a:srgbClr val="8BC5AE"/>
+                </a:solidFill>
+                <a:latin typeface="Calibri" pitchFamily="34" charset="0"/>
+                <a:ea typeface="Calibri" pitchFamily="34" charset="-122"/>
+                <a:cs typeface="Calibri" pitchFamily="34" charset="-120"/>
+              </a:rPr>
+              <a:t>PHASE 2 COMPONENTS</a:t>
+            </a:r>
+            <a:endParaRPr lang="en-US" sz="1300" dirty="0"/>
           </a:p>
         </p:txBody>
       </p:sp>
@@ -2164,8 +2688,8 @@
         </p:nvSpPr>
         <p:spPr>
           <a:xfrm>
-            <a:off x="6309360" y="2532888"/>
-            <a:ext cx="5394960" cy="685800"/>
+            <a:off x="6309360" y="1783080"/>
+            <a:ext cx="5394960" cy="502920"/>
           </a:xfrm>
           <a:prstGeom prst="rect">
             <a:avLst/>
@@ -2190,7 +2714,7 @@
                 <a:ea typeface="Calibri" pitchFamily="34" charset="-122"/>
                 <a:cs typeface="Calibri" pitchFamily="34" charset="-120"/>
               </a:rPr>
-              <a:t>Regulatory compliance mapper — procedures checked against standards, gaps flagged</a:t>
+              <a:t>Maintenance &amp; root-cause agent</a:t>
             </a:r>
             <a:endParaRPr lang="en-US" sz="1400" dirty="0"/>
           </a:p>
@@ -2204,8 +2728,8 @@
         </p:nvSpPr>
         <p:spPr>
           <a:xfrm>
-            <a:off x="6309360" y="3282696"/>
-            <a:ext cx="5394960" cy="685800"/>
+            <a:off x="6309360" y="2350008"/>
+            <a:ext cx="5394960" cy="502920"/>
           </a:xfrm>
           <a:prstGeom prst="rect">
             <a:avLst/>
@@ -2230,7 +2754,7 @@
                 <a:ea typeface="Calibri" pitchFamily="34" charset="-122"/>
                 <a:cs typeface="Calibri" pitchFamily="34" charset="-120"/>
               </a:rPr>
-              <a:t>Lessons-learned engine — recurring patterns surfaced across incident records</a:t>
+              <a:t>Regulatory compliance mapper</a:t>
             </a:r>
             <a:endParaRPr lang="en-US" sz="1400" dirty="0"/>
           </a:p>
@@ -2238,7 +2762,47 @@
       </p:sp>
       <p:sp>
         <p:nvSpPr>
-          <p:cNvPr id="12" name="Shape 10"/>
+          <p:cNvPr id="12" name="Text 10"/>
+          <p:cNvSpPr/>
+          <p:nvPr/>
+        </p:nvSpPr>
+        <p:spPr>
+          <a:xfrm>
+            <a:off x="6309360" y="2916936"/>
+            <a:ext cx="5394960" cy="502920"/>
+          </a:xfrm>
+          <a:prstGeom prst="rect">
+            <a:avLst/>
+          </a:prstGeom>
+          <a:noFill/>
+          <a:ln/>
+        </p:spPr>
+        <p:txBody>
+          <a:bodyPr wrap="square" rtlCol="0" anchor="ctr"/>
+          <a:lstStyle/>
+          <a:p>
+            <a:pPr marL="190500" indent="-190500">
+              <a:buSzPct val="100000"/>
+              <a:buChar char="•"/>
+            </a:pPr>
+            <a:r>
+              <a:rPr lang="en-US" sz="1400" dirty="0">
+                <a:solidFill>
+                  <a:srgbClr val="FFFFFF"/>
+                </a:solidFill>
+                <a:latin typeface="Calibri" pitchFamily="34" charset="0"/>
+                <a:ea typeface="Calibri" pitchFamily="34" charset="-122"/>
+                <a:cs typeface="Calibri" pitchFamily="34" charset="-120"/>
+              </a:rPr>
+              <a:t>Lessons-learned engine</a:t>
+            </a:r>
+            <a:endParaRPr lang="en-US" sz="1400" dirty="0"/>
+          </a:p>
+        </p:txBody>
+      </p:sp>
+      <p:sp>
+        <p:nvSpPr>
+          <p:cNvPr id="13" name="Shape 11"/>
           <p:cNvSpPr/>
           <p:nvPr/>
         </p:nvSpPr>
@@ -2260,7 +2824,7 @@
       </p:sp>
       <p:sp>
         <p:nvSpPr>
-          <p:cNvPr id="13" name="Text 11"/>
+          <p:cNvPr id="14" name="Text 12"/>
           <p:cNvSpPr/>
           <p:nvPr/>
         </p:nvSpPr>
@@ -2291,7 +2855,7 @@
                 <a:ea typeface="Cambria" pitchFamily="34" charset="-122"/>
                 <a:cs typeface="Cambria" pitchFamily="34" charset="-120"/>
               </a:rPr>
-              <a:t>A working, benchmarked, honestly-documented Hybrid GraphRAG system that turns scattered industrial documents into one queryable intelligence layer — and proves the difference from keyword search live, on a question only relationship reasoning can answer.</a:t>
+              <a:t>A working, benchmarked, honestly-documented Hybrid GraphRAG system that turns scattered industrial documents into one queryable intelligence layer — proving the difference on the multi-hop question this system was built for.</a:t>
             </a:r>
             <a:endParaRPr lang="en-US" sz="1600" dirty="0"/>
           </a:p>
@@ -2299,7 +2863,7 @@
       </p:sp>
       <p:sp>
         <p:nvSpPr>
-          <p:cNvPr id="14" name="Text 12"/>
+          <p:cNvPr id="15" name="Text 13"/>
           <p:cNvSpPr/>
           <p:nvPr/>
         </p:nvSpPr>
@@ -2330,7 +2894,7 @@
                 <a:ea typeface="Calibri" pitchFamily="34" charset="-122"/>
                 <a:cs typeface="Calibri" pitchFamily="34" charset="-120"/>
               </a:rPr>
-              <a:t>ET AI Hackathon 2.0  ·  Problem #8  ·  Industrial Knowledge Intelligence</a:t>
+              <a:t>ET AI Hackathon 2.0  ·  Problem #8  ·  Industrial Knowledge Intelligence (Revised)</a:t>
             </a:r>
             <a:endParaRPr lang="en-US" sz="900" dirty="0"/>
           </a:p>
@@ -2338,7 +2902,7 @@
       </p:sp>
       <p:sp>
         <p:nvSpPr>
-          <p:cNvPr id="15" name="Text 13"/>
+          <p:cNvPr id="16" name="Text 14"/>
           <p:cNvSpPr/>
           <p:nvPr/>
         </p:nvSpPr>
@@ -2369,7 +2933,7 @@
                 <a:ea typeface="Calibri" pitchFamily="34" charset="-122"/>
                 <a:cs typeface="Calibri" pitchFamily="34" charset="-120"/>
               </a:rPr>
-              <a:t>10</a:t>
+              <a:t>11</a:t>
             </a:r>
             <a:endParaRPr lang="en-US" sz="900" dirty="0"/>
           </a:p>
@@ -2840,7 +3404,7 @@
                 <a:ea typeface="Calibri" pitchFamily="34" charset="-122"/>
                 <a:cs typeface="Calibri" pitchFamily="34" charset="-120"/>
               </a:rPr>
-              <a:t>An estimated 25% of India's experienced industrial engineers retire within the decade — taking decades of undocumented operational knowledge with them. The signals to prevent failures usually exist across separate records; no layer connects them into a decision in time.</a:t>
+              <a:t>An estimated 25% of India's experienced industrial engineers retire within the decade, taking decades of undocumented operational knowledge with them. The signals to prevent failures usually exist across separate records; no layer connects them into a decision in time.</a:t>
             </a:r>
             <a:endParaRPr lang="en-US" sz="1450" dirty="0"/>
           </a:p>
@@ -2879,7 +3443,7 @@
                 <a:ea typeface="Calibri" pitchFamily="34" charset="-122"/>
                 <a:cs typeface="Calibri" pitchFamily="34" charset="-120"/>
               </a:rPr>
-              <a:t>ET AI Hackathon 2.0  ·  Problem #8  ·  Industrial Knowledge Intelligence</a:t>
+              <a:t>ET AI Hackathon 2.0  ·  Problem #8  ·  Industrial Knowledge Intelligence (Revised)</a:t>
             </a:r>
             <a:endParaRPr lang="en-US" sz="900" dirty="0"/>
           </a:p>
@@ -3089,7 +3653,7 @@
                 <a:ea typeface="Calibri" pitchFamily="34" charset="-122"/>
                 <a:cs typeface="Calibri" pitchFamily="34" charset="-120"/>
               </a:rPr>
-              <a:t>Strong on semantic lookup, blind to relationship reasoning. Multi-hop questions — which most industrial knowledge work needs — are exactly where it fails.</a:t>
+              <a:t>Strong on semantic lookup, blind to relationship reasoning. Multi-hop questions are exactly where it fails.</a:t>
             </a:r>
             <a:endParaRPr lang="en-US" sz="1400" dirty="0"/>
           </a:p>
@@ -3228,7 +3792,7 @@
                 <a:ea typeface="Calibri" pitchFamily="34" charset="-122"/>
                 <a:cs typeface="Calibri" pitchFamily="34" charset="-120"/>
               </a:rPr>
-              <a:t>Elegant, but brittle. If entity extraction misses something during ingestion, that information is gone with no fallback.</a:t>
+              <a:t>Elegant, but brittle. If entity extraction misses something, that information is gone with no fallback.</a:t>
             </a:r>
             <a:endParaRPr lang="en-US" sz="1400" dirty="0"/>
           </a:p>
@@ -3367,7 +3931,7 @@
                 <a:ea typeface="Calibri" pitchFamily="34" charset="-122"/>
                 <a:cs typeface="Calibri" pitchFamily="34" charset="-120"/>
               </a:rPr>
-              <a:t>Graph for relationship reasoning, vector store as safety net, fused by Reciprocal Rank Fusion. The empirically stronger architecture in recent enterprise research.</a:t>
+              <a:t>Graph for relationship reasoning, vector store as safety net, fused by Reciprocal Rank Fusion.</a:t>
             </a:r>
             <a:endParaRPr lang="en-US" sz="1400" dirty="0"/>
           </a:p>
@@ -3445,7 +4009,7 @@
                 <a:ea typeface="Calibri" pitchFamily="34" charset="-122"/>
                 <a:cs typeface="Calibri" pitchFamily="34" charset="-120"/>
               </a:rPr>
-              <a:t>ET AI Hackathon 2.0  ·  Problem #8  ·  Industrial Knowledge Intelligence</a:t>
+              <a:t>ET AI Hackathon 2.0  ·  Problem #8  ·  Industrial Knowledge Intelligence (Revised)</a:t>
             </a:r>
             <a:endParaRPr lang="en-US" sz="900" dirty="0"/>
           </a:p>
@@ -3594,7 +4158,7 @@
                 <a:ea typeface="Calibri" pitchFamily="34" charset="-122"/>
                 <a:cs typeface="Calibri" pitchFamily="34" charset="-120"/>
               </a:rPr>
-              <a:t>A document enters at the left; a cited answer leaves at the right. The defining feature is the fork and merge in the middle — graph and vector store are built and queried independently, then fused.</a:t>
+              <a:t>A document enters at the left; a cited answer leaves at the right. Graph and vector store are built and queried independently, then fused.</a:t>
             </a:r>
             <a:endParaRPr lang="en-US" sz="1400" dirty="0"/>
           </a:p>
@@ -3657,7 +4221,7 @@
                 <a:ea typeface="Calibri" pitchFamily="34" charset="-122"/>
                 <a:cs typeface="Calibri" pitchFamily="34" charset="-120"/>
               </a:rPr>
-              <a:t>ET AI Hackathon 2.0  ·  Problem #8  ·  Industrial Knowledge Intelligence</a:t>
+              <a:t>ET AI Hackathon 2.0  ·  Problem #8  ·  Industrial Knowledge Intelligence (Revised)</a:t>
             </a:r>
             <a:endParaRPr lang="en-US" sz="900" dirty="0"/>
           </a:p>
@@ -3767,7 +4331,7 @@
                 <a:ea typeface="Cambria" pitchFamily="34" charset="-122"/>
                 <a:cs typeface="Cambria" pitchFamily="34" charset="-120"/>
               </a:rPr>
-              <a:t>The proof: a five-hop chain keyword search can't follow</a:t>
+              <a:t>The proof: a five-hop chain vector-only search misses</a:t>
             </a:r>
             <a:endParaRPr lang="en-US" sz="3000" dirty="0"/>
           </a:p>
@@ -4284,7 +4848,7 @@
                 <a:ea typeface="Calibri" pitchFamily="34" charset="-122"/>
                 <a:cs typeface="Calibri" pitchFamily="34" charset="-120"/>
               </a:rPr>
-              <a:t>THE STAR QUESTION</a:t>
+              <a:t>RESULT</a:t>
             </a:r>
             <a:endParaRPr lang="en-US" sz="1200" dirty="0"/>
           </a:p>
@@ -4298,8 +4862,8 @@
         </p:nvSpPr>
         <p:spPr>
           <a:xfrm>
-            <a:off x="7909560" y="1965960"/>
-            <a:ext cx="3657600" cy="1371600"/>
+            <a:off x="7909560" y="1920240"/>
+            <a:ext cx="3657600" cy="640080"/>
           </a:xfrm>
           <a:prstGeom prst="rect">
             <a:avLst/>
@@ -4315,7 +4879,7 @@
               <a:buNone/>
             </a:pPr>
             <a:r>
-              <a:rPr lang="en-US" sz="1800" b="1" i="1" dirty="0">
+              <a:rPr lang="en-US" sz="2600" b="1" dirty="0">
                 <a:solidFill>
                   <a:srgbClr val="FFFFFF"/>
                 </a:solidFill>
@@ -4323,9 +4887,9 @@
                 <a:ea typeface="Cambria" pitchFamily="34" charset="-122"/>
                 <a:cs typeface="Cambria" pitchFamily="34" charset="-120"/>
               </a:rPr>
-              <a:t>"Was there any early warning before the Pump P-204 failure, and what should have been done?"</a:t>
-            </a:r>
-            <a:endParaRPr lang="en-US" sz="1800" dirty="0"/>
+              <a:t>Q01 recall: 0.80 → 1.00</a:t>
+            </a:r>
+            <a:endParaRPr lang="en-US" sz="2600" dirty="0"/>
           </a:p>
         </p:txBody>
       </p:sp>
@@ -4337,8 +4901,8 @@
         </p:nvSpPr>
         <p:spPr>
           <a:xfrm>
-            <a:off x="7909560" y="3520440"/>
-            <a:ext cx="3657600" cy="822960"/>
+            <a:off x="7909560" y="2514600"/>
+            <a:ext cx="3657600" cy="365760"/>
           </a:xfrm>
           <a:prstGeom prst="rect">
             <a:avLst/>
@@ -4354,7 +4918,7 @@
               <a:buNone/>
             </a:pPr>
             <a:r>
-              <a:rPr lang="en-US" sz="1300" dirty="0">
+              <a:rPr lang="en-US" sz="1300" i="1" dirty="0">
                 <a:solidFill>
                   <a:srgbClr val="E1F5EE"/>
                 </a:solidFill>
@@ -4362,7 +4926,7 @@
                 <a:ea typeface="Calibri" pitchFamily="34" charset="-122"/>
                 <a:cs typeface="Calibri" pitchFamily="34" charset="-120"/>
               </a:rPr>
-              <a:t>Keyword search returns only the incident report. Graph traversal recovers the full chain.</a:t>
+              <a:t>(vector-only → hybrid)</a:t>
             </a:r>
             <a:endParaRPr lang="en-US" sz="1300" dirty="0"/>
           </a:p>
@@ -4371,6 +4935,45 @@
       <p:sp>
         <p:nvSpPr>
           <p:cNvPr id="19" name="Text 17"/>
+          <p:cNvSpPr/>
+          <p:nvPr/>
+        </p:nvSpPr>
+        <p:spPr>
+          <a:xfrm>
+            <a:off x="7909560" y="3017520"/>
+            <a:ext cx="3657600" cy="1371600"/>
+          </a:xfrm>
+          <a:prstGeom prst="rect">
+            <a:avLst/>
+          </a:prstGeom>
+          <a:noFill/>
+          <a:ln/>
+        </p:spPr>
+        <p:txBody>
+          <a:bodyPr wrap="square" rtlCol="0" anchor="ctr"/>
+          <a:lstStyle/>
+          <a:p>
+            <a:pPr indent="0" marL="0">
+              <a:buNone/>
+            </a:pPr>
+            <a:r>
+              <a:rPr lang="en-US" sz="1250" dirty="0">
+                <a:solidFill>
+                  <a:srgbClr val="FFFFFF"/>
+                </a:solidFill>
+                <a:latin typeface="Calibri" pitchFamily="34" charset="0"/>
+                <a:ea typeface="Calibri" pitchFamily="34" charset="-122"/>
+                <a:cs typeface="Calibri" pitchFamily="34" charset="-120"/>
+              </a:rPr>
+              <a:t>The full five-document chain is now retrieved. Hybrid recovers exactly what vector-only search misses: VS-204 and M-118, the two documents whose text never mentions "P-204" directly.</a:t>
+            </a:r>
+            <a:endParaRPr lang="en-US" sz="1250" dirty="0"/>
+          </a:p>
+        </p:txBody>
+      </p:sp>
+      <p:sp>
+        <p:nvSpPr>
+          <p:cNvPr id="20" name="Text 18"/>
           <p:cNvSpPr/>
           <p:nvPr/>
         </p:nvSpPr>
@@ -4401,7 +5004,7 @@
                 <a:ea typeface="Calibri" pitchFamily="34" charset="-122"/>
                 <a:cs typeface="Calibri" pitchFamily="34" charset="-120"/>
               </a:rPr>
-              <a:t>Five documents, no shared keywords. Only relationship reasoning connects them into the answer.</a:t>
+              <a:t>Five documents, no shared keywords. Relationship reasoning connects them into the answer.</a:t>
             </a:r>
             <a:endParaRPr lang="en-US" sz="1400" dirty="0"/>
           </a:p>
@@ -4409,7 +5012,7 @@
       </p:sp>
       <p:sp>
         <p:nvSpPr>
-          <p:cNvPr id="20" name="Text 18"/>
+          <p:cNvPr id="21" name="Text 19"/>
           <p:cNvSpPr/>
           <p:nvPr/>
         </p:nvSpPr>
@@ -4440,7 +5043,7 @@
                 <a:ea typeface="Calibri" pitchFamily="34" charset="-122"/>
                 <a:cs typeface="Calibri" pitchFamily="34" charset="-120"/>
               </a:rPr>
-              <a:t>ET AI Hackathon 2.0  ·  Problem #8  ·  Industrial Knowledge Intelligence</a:t>
+              <a:t>ET AI Hackathon 2.0  ·  Problem #8  ·  Industrial Knowledge Intelligence (Revised)</a:t>
             </a:r>
             <a:endParaRPr lang="en-US" sz="900" dirty="0"/>
           </a:p>
@@ -4448,7 +5051,7 @@
       </p:sp>
       <p:sp>
         <p:nvSpPr>
-          <p:cNvPr id="21" name="Text 19"/>
+          <p:cNvPr id="22" name="Text 20"/>
           <p:cNvSpPr/>
           <p:nvPr/>
         </p:nvSpPr>
@@ -4589,7 +5192,7 @@
                 <a:ea typeface="Calibri" pitchFamily="34" charset="-122"/>
                 <a:cs typeface="Calibri" pitchFamily="34" charset="-120"/>
               </a:rPr>
-              <a:t>The same three-layer agentic pattern that runs a live production system maps directly onto this build. The build risk was in execution, not in learning an unfamiliar stack under a deadline.</a:t>
+              <a:t>The same three-layer agentic pattern that runs a live production system maps directly onto this build.</a:t>
             </a:r>
             <a:endParaRPr lang="en-US" sz="1400" dirty="0"/>
           </a:p>
@@ -5544,7 +6147,7 @@
                 <a:ea typeface="Calibri" pitchFamily="34" charset="-122"/>
                 <a:cs typeface="Calibri" pitchFamily="34" charset="-120"/>
               </a:rPr>
-              <a:t>ET AI Hackathon 2.0  ·  Problem #8  ·  Industrial Knowledge Intelligence</a:t>
+              <a:t>ET AI Hackathon 2.0  ·  Problem #8  ·  Industrial Knowledge Intelligence (Revised)</a:t>
             </a:r>
             <a:endParaRPr lang="en-US" sz="900" dirty="0"/>
           </a:p>
@@ -6181,7 +6784,7 @@
                 <a:ea typeface="Calibri" pitchFamily="34" charset="-122"/>
                 <a:cs typeface="Calibri" pitchFamily="34" charset="-120"/>
               </a:rPr>
-              <a:t>IBM Research, NeurIPS 2025, CC-BY-4.0 — 8,296 industrial QA pairs as reference benchmark</a:t>
+              <a:t>IBM Research, NeurIPS 2025, CC-BY-4.0 — 8,296 QA pairs as reference benchmark</a:t>
             </a:r>
             <a:endParaRPr lang="en-US" sz="1200" dirty="0"/>
           </a:p>
@@ -6464,7 +7067,7 @@
                 <a:ea typeface="Calibri" pitchFamily="34" charset="-122"/>
                 <a:cs typeface="Calibri" pitchFamily="34" charset="-120"/>
               </a:rPr>
-              <a:t>ET AI Hackathon 2.0  ·  Problem #8  ·  Industrial Knowledge Intelligence</a:t>
+              <a:t>ET AI Hackathon 2.0  ·  Problem #8  ·  Industrial Knowledge Intelligence (Revised)</a:t>
             </a:r>
             <a:endParaRPr lang="en-US" sz="900" dirty="0"/>
           </a:p>
@@ -6627,7 +7230,7 @@
               <a:buNone/>
             </a:pPr>
             <a:r>
-              <a:rPr lang="en-US" sz="5200" b="1" dirty="0">
+              <a:rPr lang="en-US" sz="4600" b="1" dirty="0">
                 <a:solidFill>
                   <a:srgbClr val="0F6E56"/>
                 </a:solidFill>
@@ -6637,7 +7240,7 @@
               </a:rPr>
               <a:t>0.8411</a:t>
             </a:r>
-            <a:endParaRPr lang="en-US" sz="5200" dirty="0"/>
+            <a:endParaRPr lang="en-US" sz="4600" dirty="0"/>
           </a:p>
         </p:txBody>
       </p:sp>
@@ -6766,7 +7369,7 @@
               <a:buNone/>
             </a:pPr>
             <a:r>
-              <a:rPr lang="en-US" sz="5200" b="1" dirty="0">
+              <a:rPr lang="en-US" sz="4600" b="1" dirty="0">
                 <a:solidFill>
                   <a:srgbClr val="1F3864"/>
                 </a:solidFill>
@@ -6774,9 +7377,9 @@
                 <a:ea typeface="Cambria" pitchFamily="34" charset="-122"/>
                 <a:cs typeface="Cambria" pitchFamily="34" charset="-120"/>
               </a:rPr>
-              <a:t>0.60</a:t>
-            </a:r>
-            <a:endParaRPr lang="en-US" sz="5200" dirty="0"/>
+              <a:t>1.00</a:t>
+            </a:r>
+            <a:endParaRPr lang="en-US" sz="4600" dirty="0"/>
           </a:p>
         </p:txBody>
       </p:sp>
@@ -6852,7 +7455,7 @@
                 <a:ea typeface="Calibri" pitchFamily="34" charset="-122"/>
                 <a:cs typeface="Calibri" pitchFamily="34" charset="-120"/>
               </a:rPr>
-              <a:t>Multi-hop, graph-only retrieval</a:t>
+              <a:t>Full 5-doc chain retrieved (was 0.60)</a:t>
             </a:r>
             <a:endParaRPr lang="en-US" sz="1100" dirty="0"/>
           </a:p>
@@ -6905,7 +7508,7 @@
               <a:buNone/>
             </a:pPr>
             <a:r>
-              <a:rPr lang="en-US" sz="5200" b="1" dirty="0">
+              <a:rPr lang="en-US" sz="3400" b="1" dirty="0">
                 <a:solidFill>
                   <a:srgbClr val="993C1D"/>
                 </a:solidFill>
@@ -6913,9 +7516,9 @@
                 <a:ea typeface="Cambria" pitchFamily="34" charset="-122"/>
                 <a:cs typeface="Cambria" pitchFamily="34" charset="-120"/>
               </a:rPr>
-              <a:t>0.78</a:t>
-            </a:r>
-            <a:endParaRPr lang="en-US" sz="5200" dirty="0"/>
+              <a:t>0.83 / 0.81</a:t>
+            </a:r>
+            <a:endParaRPr lang="en-US" sz="3400" dirty="0"/>
           </a:p>
         </p:txBody>
       </p:sp>
@@ -6952,7 +7555,7 @@
                 <a:ea typeface="Calibri" pitchFamily="34" charset="-122"/>
                 <a:cs typeface="Calibri" pitchFamily="34" charset="-120"/>
               </a:rPr>
-              <a:t>Overall hybrid recall</a:t>
+              <a:t>Overall recall, hybrid / vector</a:t>
             </a:r>
             <a:endParaRPr lang="en-US" sz="1400" dirty="0"/>
           </a:p>
@@ -6991,7 +7594,7 @@
                 <a:ea typeface="Calibri" pitchFamily="34" charset="-122"/>
                 <a:cs typeface="Calibri" pitchFamily="34" charset="-120"/>
               </a:rPr>
-              <a:t>Across 8 benchmark questions</a:t>
+              <a:t>Top-12 across 8 questions</a:t>
             </a:r>
             <a:endParaRPr lang="en-US" sz="1100" dirty="0"/>
           </a:p>
@@ -7052,7 +7655,7 @@
                 <a:ea typeface="Calibri" pitchFamily="34" charset="-122"/>
                 <a:cs typeface="Calibri" pitchFamily="34" charset="-120"/>
               </a:rPr>
-              <a:t>Reproducibility, found and fixed</a:t>
+              <a:t>Honest reading, stated directly</a:t>
             </a:r>
             <a:endParaRPr lang="en-US" sz="1600" dirty="0"/>
           </a:p>
@@ -7083,7 +7686,7 @@
               <a:buNone/>
             </a:pPr>
             <a:r>
-              <a:rPr lang="en-US" sz="1350" dirty="0">
+              <a:rPr lang="en-US" sz="1300" dirty="0">
                 <a:solidFill>
                   <a:srgbClr val="FFFFFF"/>
                 </a:solidFill>
@@ -7091,9 +7694,9 @@
                 <a:ea typeface="Calibri" pitchFamily="34" charset="-122"/>
                 <a:cs typeface="Calibri" pitchFamily="34" charset="-120"/>
               </a:rPr>
-              <a:t>Early benchmark numbers varied across identical runs. Root cause: unstable tie-break ordering in graph ranking, sensitive to per-process hash randomisation. Fixed with a deterministic tie-break key and verified by repeated identical runs. Every metric above is post-fix — and control questions stay at 1.00, confirming hybrid loses nothing on simple lookups.</a:t>
-            </a:r>
-            <a:endParaRPr lang="en-US" sz="1350" dirty="0"/>
+              <a:t>A stronger embedding model lifted the vector-only baseline too, so the aggregate hybrid margin is now small — and at a stricter top-5 cutoff, hybrid trails vector-only (0.70 vs 0.76). The graph earns its place on the multi-hop question this system was built for (Q01: 0.80 → 1.00), not on aggregate averages.</a:t>
+            </a:r>
+            <a:endParaRPr lang="en-US" sz="1300" dirty="0"/>
           </a:p>
         </p:txBody>
       </p:sp>
@@ -7130,7 +7733,7 @@
                 <a:ea typeface="Calibri" pitchFamily="34" charset="-122"/>
                 <a:cs typeface="Calibri" pitchFamily="34" charset="-120"/>
               </a:rPr>
-              <a:t>ET AI Hackathon 2.0  ·  Problem #8  ·  Industrial Knowledge Intelligence</a:t>
+              <a:t>ET AI Hackathon 2.0  ·  Problem #8  ·  Industrial Knowledge Intelligence (Revised)</a:t>
             </a:r>
             <a:endParaRPr lang="en-US" sz="900" dirty="0"/>
           </a:p>
@@ -7232,7 +7835,7 @@
               <a:buNone/>
             </a:pPr>
             <a:r>
-              <a:rPr lang="en-US" sz="3200" b="1" dirty="0">
+              <a:rPr lang="en-US" sz="2800" b="1" dirty="0">
                 <a:solidFill>
                   <a:srgbClr val="1F3864"/>
                 </a:solidFill>
@@ -7240,65 +7843,26 @@
                 <a:ea typeface="Cambria" pitchFamily="34" charset="-122"/>
                 <a:cs typeface="Cambria" pitchFamily="34" charset="-120"/>
               </a:rPr>
-              <a:t>Known limitations — documented, not hidden</a:t>
-            </a:r>
-            <a:endParaRPr lang="en-US" sz="3200" dirty="0"/>
-          </a:p>
-        </p:txBody>
-      </p:sp>
-      <p:sp>
-        <p:nvSpPr>
-          <p:cNvPr id="3" name="Text 1"/>
-          <p:cNvSpPr/>
-          <p:nvPr/>
-        </p:nvSpPr>
-        <p:spPr>
-          <a:xfrm>
-            <a:off x="457200" y="1051560"/>
-            <a:ext cx="11247120" cy="548640"/>
-          </a:xfrm>
-          <a:prstGeom prst="rect">
-            <a:avLst/>
-          </a:prstGeom>
-          <a:noFill/>
-          <a:ln/>
-        </p:spPr>
-        <p:txBody>
-          <a:bodyPr wrap="square" rtlCol="0" anchor="ctr"/>
-          <a:lstStyle/>
-          <a:p>
-            <a:pPr indent="0" marL="0">
-              <a:buNone/>
-            </a:pPr>
-            <a:r>
-              <a:rPr lang="en-US" sz="1500" i="1" dirty="0">
-                <a:solidFill>
-                  <a:srgbClr val="1A1A1A"/>
-                </a:solidFill>
-                <a:latin typeface="Calibri" pitchFamily="34" charset="0"/>
-                <a:ea typeface="Calibri" pitchFamily="34" charset="-122"/>
-                <a:cs typeface="Calibri" pitchFamily="34" charset="-120"/>
-              </a:rPr>
-              <a:t>Understanding a system's failure modes precisely is more valuable than pretending they don't exist. Each has a traced root cause.</a:t>
-            </a:r>
-            <a:endParaRPr lang="en-US" sz="1500" dirty="0"/>
-          </a:p>
-        </p:txBody>
-      </p:sp>
-      <p:sp>
-        <p:nvSpPr>
-          <p:cNvPr id="4" name="Shape 2"/>
-          <p:cNvSpPr/>
-          <p:nvPr/>
-        </p:nvSpPr>
-        <p:spPr>
-          <a:xfrm>
-            <a:off x="457200" y="1783080"/>
-            <a:ext cx="11247120" cy="1234440"/>
+              <a:t>Second hardening pass — found, fixed, honestly verified</a:t>
+            </a:r>
+            <a:endParaRPr lang="en-US" sz="2800" dirty="0"/>
+          </a:p>
+        </p:txBody>
+      </p:sp>
+      <p:sp>
+        <p:nvSpPr>
+          <p:cNvPr id="3" name="Shape 1"/>
+          <p:cNvSpPr/>
+          <p:nvPr/>
+        </p:nvSpPr>
+        <p:spPr>
+          <a:xfrm>
+            <a:off x="457200" y="1463040"/>
+            <a:ext cx="5440680" cy="1783080"/>
           </a:xfrm>
           <a:prstGeom prst="roundRect">
             <a:avLst>
-              <a:gd name="adj" fmla="val 5926"/>
+              <a:gd name="adj" fmla="val 4103"/>
             </a:avLst>
           </a:prstGeom>
           <a:solidFill>
@@ -7309,96 +7873,118 @@
       </p:sp>
       <p:sp>
         <p:nvSpPr>
-          <p:cNvPr id="5" name="Text 3"/>
-          <p:cNvSpPr/>
-          <p:nvPr/>
-        </p:nvSpPr>
-        <p:spPr>
-          <a:xfrm>
-            <a:off x="731520" y="1947672"/>
-            <a:ext cx="10698480" cy="411480"/>
-          </a:xfrm>
-          <a:prstGeom prst="rect">
-            <a:avLst/>
-          </a:prstGeom>
-          <a:noFill/>
-          <a:ln/>
-        </p:spPr>
-        <p:txBody>
-          <a:bodyPr wrap="square" rtlCol="0" anchor="ctr"/>
-          <a:lstStyle/>
-          <a:p>
-            <a:pPr indent="0" marL="0">
-              <a:buNone/>
-            </a:pPr>
-            <a:r>
-              <a:rPr lang="en-US" sz="1700" b="1" dirty="0">
-                <a:solidFill>
-                  <a:srgbClr val="993C1D"/>
-                </a:solidFill>
-                <a:latin typeface="Calibri" pitchFamily="34" charset="0"/>
-                <a:ea typeface="Calibri" pitchFamily="34" charset="-122"/>
-                <a:cs typeface="Calibri" pitchFamily="34" charset="-120"/>
-              </a:rPr>
-              <a:t>Hop-tier tie-flooding (Q02)</a:t>
-            </a:r>
-            <a:endParaRPr lang="en-US" sz="1700" dirty="0"/>
-          </a:p>
-        </p:txBody>
-      </p:sp>
-      <p:sp>
-        <p:nvSpPr>
-          <p:cNvPr id="6" name="Text 4"/>
-          <p:cNvSpPr/>
-          <p:nvPr/>
-        </p:nvSpPr>
-        <p:spPr>
-          <a:xfrm>
-            <a:off x="731520" y="2331720"/>
-            <a:ext cx="10698480" cy="594360"/>
-          </a:xfrm>
-          <a:prstGeom prst="rect">
-            <a:avLst/>
-          </a:prstGeom>
-          <a:noFill/>
-          <a:ln/>
-        </p:spPr>
-        <p:txBody>
-          <a:bodyPr wrap="square" rtlCol="0" anchor="ctr"/>
-          <a:lstStyle/>
-          <a:p>
-            <a:pPr indent="0" marL="0">
-              <a:buNone/>
-            </a:pPr>
-            <a:r>
-              <a:rPr lang="en-US" sz="1350" dirty="0">
-                <a:solidFill>
-                  <a:srgbClr val="1A1A1A"/>
-                </a:solidFill>
-                <a:latin typeface="Calibri" pitchFamily="34" charset="0"/>
-                <a:ea typeface="Calibri" pitchFamily="34" charset="-122"/>
-                <a:cs typeface="Calibri" pitchFamily="34" charset="-120"/>
-              </a:rPr>
-              <a:t>Many documents share an identical graph score for merely mentioning the query entity, crowding out a more specific but structurally-further answer. Two fixes attempted and precisely diagnosed.</a:t>
-            </a:r>
-            <a:endParaRPr lang="en-US" sz="1350" dirty="0"/>
-          </a:p>
-        </p:txBody>
-      </p:sp>
-      <p:sp>
-        <p:nvSpPr>
-          <p:cNvPr id="7" name="Shape 5"/>
-          <p:cNvSpPr/>
-          <p:nvPr/>
-        </p:nvSpPr>
-        <p:spPr>
-          <a:xfrm>
-            <a:off x="457200" y="3200400"/>
-            <a:ext cx="11247120" cy="1234440"/>
+          <p:cNvPr id="4" name="Shape 2"/>
+          <p:cNvSpPr/>
+          <p:nvPr/>
+        </p:nvSpPr>
+        <p:spPr>
+          <a:xfrm>
+            <a:off x="640080" y="1645920"/>
+            <a:ext cx="109728" cy="1417320"/>
           </a:xfrm>
           <a:prstGeom prst="roundRect">
             <a:avLst>
-              <a:gd name="adj" fmla="val 5926"/>
+              <a:gd name="adj" fmla="val 41667"/>
+            </a:avLst>
+          </a:prstGeom>
+          <a:solidFill>
+            <a:srgbClr val="0F6E56"/>
+          </a:solidFill>
+          <a:ln/>
+        </p:spPr>
+      </p:sp>
+      <p:sp>
+        <p:nvSpPr>
+          <p:cNvPr id="5" name="Text 3"/>
+          <p:cNvSpPr/>
+          <p:nvPr/>
+        </p:nvSpPr>
+        <p:spPr>
+          <a:xfrm>
+            <a:off x="868680" y="1600200"/>
+            <a:ext cx="4846320" cy="457200"/>
+          </a:xfrm>
+          <a:prstGeom prst="rect">
+            <a:avLst/>
+          </a:prstGeom>
+          <a:noFill/>
+          <a:ln/>
+        </p:spPr>
+        <p:txBody>
+          <a:bodyPr wrap="square" rtlCol="0" anchor="ctr"/>
+          <a:lstStyle/>
+          <a:p>
+            <a:pPr indent="0" marL="0">
+              <a:buNone/>
+            </a:pPr>
+            <a:r>
+              <a:rPr lang="en-US" sz="1400" b="1" dirty="0">
+                <a:solidFill>
+                  <a:srgbClr val="0F6E56"/>
+                </a:solidFill>
+                <a:latin typeface="Calibri" pitchFamily="34" charset="0"/>
+                <a:ea typeface="Calibri" pitchFamily="34" charset="-122"/>
+                <a:cs typeface="Calibri" pitchFamily="34" charset="-120"/>
+              </a:rPr>
+              <a:t>Embedding truncation bug — found and fixed</a:t>
+            </a:r>
+            <a:endParaRPr lang="en-US" sz="1400" dirty="0"/>
+          </a:p>
+        </p:txBody>
+      </p:sp>
+      <p:sp>
+        <p:nvSpPr>
+          <p:cNvPr id="6" name="Text 4"/>
+          <p:cNvSpPr/>
+          <p:nvPr/>
+        </p:nvSpPr>
+        <p:spPr>
+          <a:xfrm>
+            <a:off x="868680" y="2057400"/>
+            <a:ext cx="4892040" cy="1097280"/>
+          </a:xfrm>
+          <a:prstGeom prst="rect">
+            <a:avLst/>
+          </a:prstGeom>
+          <a:noFill/>
+          <a:ln/>
+        </p:spPr>
+        <p:txBody>
+          <a:bodyPr wrap="square" rtlCol="0" anchor="ctr"/>
+          <a:lstStyle/>
+          <a:p>
+            <a:pPr indent="0" marL="0">
+              <a:buNone/>
+            </a:pPr>
+            <a:r>
+              <a:rPr lang="en-US" sz="1150" dirty="0">
+                <a:solidFill>
+                  <a:srgbClr val="1A1A1A"/>
+                </a:solidFill>
+                <a:latin typeface="Calibri" pitchFamily="34" charset="0"/>
+                <a:ea typeface="Calibri" pitchFamily="34" charset="-122"/>
+                <a:cs typeface="Calibri" pitchFamily="34" charset="-120"/>
+              </a:rPr>
+              <a:t>The original model silently cut off long pages at ~256 tokens. Switched to a 512-token model with overlapping windows — the direct cause of the retrieval gains.</a:t>
+            </a:r>
+            <a:endParaRPr lang="en-US" sz="1150" dirty="0"/>
+          </a:p>
+        </p:txBody>
+      </p:sp>
+      <p:sp>
+        <p:nvSpPr>
+          <p:cNvPr id="7" name="Shape 5"/>
+          <p:cNvSpPr/>
+          <p:nvPr/>
+        </p:nvSpPr>
+        <p:spPr>
+          <a:xfrm>
+            <a:off x="6172200" y="1463040"/>
+            <a:ext cx="5440680" cy="1783080"/>
+          </a:xfrm>
+          <a:prstGeom prst="roundRect">
+            <a:avLst>
+              <a:gd name="adj" fmla="val 4103"/>
             </a:avLst>
           </a:prstGeom>
           <a:solidFill>
@@ -7409,114 +7995,36 @@
       </p:sp>
       <p:sp>
         <p:nvSpPr>
-          <p:cNvPr id="8" name="Text 6"/>
-          <p:cNvSpPr/>
-          <p:nvPr/>
-        </p:nvSpPr>
-        <p:spPr>
-          <a:xfrm>
-            <a:off x="731520" y="3364992"/>
-            <a:ext cx="10698480" cy="411480"/>
-          </a:xfrm>
-          <a:prstGeom prst="rect">
-            <a:avLst/>
-          </a:prstGeom>
-          <a:noFill/>
-          <a:ln/>
-        </p:spPr>
-        <p:txBody>
-          <a:bodyPr wrap="square" rtlCol="0" anchor="ctr"/>
-          <a:lstStyle/>
-          <a:p>
-            <a:pPr indent="0" marL="0">
-              <a:buNone/>
-            </a:pPr>
-            <a:r>
-              <a:rPr lang="en-US" sz="1700" b="1" dirty="0">
-                <a:solidFill>
-                  <a:srgbClr val="993C1D"/>
-                </a:solidFill>
-                <a:latin typeface="Calibri" pitchFamily="34" charset="0"/>
-                <a:ea typeface="Calibri" pitchFamily="34" charset="-122"/>
-                <a:cs typeface="Calibri" pitchFamily="34" charset="-120"/>
-              </a:rPr>
-              <a:t>Supporting-document cutoff (Q01)</a:t>
-            </a:r>
-            <a:endParaRPr lang="en-US" sz="1700" dirty="0"/>
-          </a:p>
-        </p:txBody>
-      </p:sp>
-      <p:sp>
-        <p:nvSpPr>
-          <p:cNvPr id="9" name="Text 7"/>
-          <p:cNvSpPr/>
-          <p:nvPr/>
-        </p:nvSpPr>
-        <p:spPr>
-          <a:xfrm>
-            <a:off x="731520" y="3749040"/>
-            <a:ext cx="10698480" cy="594360"/>
-          </a:xfrm>
-          <a:prstGeom prst="rect">
-            <a:avLst/>
-          </a:prstGeom>
-          <a:noFill/>
-          <a:ln/>
-        </p:spPr>
-        <p:txBody>
-          <a:bodyPr wrap="square" rtlCol="0" anchor="ctr"/>
-          <a:lstStyle/>
-          <a:p>
-            <a:pPr indent="0" marL="0">
-              <a:buNone/>
-            </a:pPr>
-            <a:r>
-              <a:rPr lang="en-US" sz="1350" dirty="0">
-                <a:solidFill>
-                  <a:srgbClr val="1A1A1A"/>
-                </a:solidFill>
-                <a:latin typeface="Calibri" pitchFamily="34" charset="0"/>
-                <a:ea typeface="Calibri" pitchFamily="34" charset="-122"/>
-                <a:cs typeface="Calibri" pitchFamily="34" charset="-120"/>
-              </a:rPr>
-              <a:t>One supporting document occasionally ranks just outside the retrieval cutoff — the same tie-flooding pattern. The answer's narrative stays correct; one corroborating detail can be omitted.</a:t>
-            </a:r>
-            <a:endParaRPr lang="en-US" sz="1350" dirty="0"/>
-          </a:p>
-        </p:txBody>
-      </p:sp>
-      <p:sp>
-        <p:nvSpPr>
-          <p:cNvPr id="10" name="Shape 8"/>
-          <p:cNvSpPr/>
-          <p:nvPr/>
-        </p:nvSpPr>
-        <p:spPr>
-          <a:xfrm>
-            <a:off x="457200" y="4709160"/>
-            <a:ext cx="11247120" cy="914400"/>
+          <p:cNvPr id="8" name="Shape 6"/>
+          <p:cNvSpPr/>
+          <p:nvPr/>
+        </p:nvSpPr>
+        <p:spPr>
+          <a:xfrm>
+            <a:off x="6355080" y="1645920"/>
+            <a:ext cx="109728" cy="1417320"/>
           </a:xfrm>
           <a:prstGeom prst="roundRect">
             <a:avLst>
-              <a:gd name="adj" fmla="val 8000"/>
+              <a:gd name="adj" fmla="val 41667"/>
             </a:avLst>
           </a:prstGeom>
           <a:solidFill>
-            <a:srgbClr val="E1F5EE"/>
+            <a:srgbClr val="2F5496"/>
           </a:solidFill>
           <a:ln/>
         </p:spPr>
       </p:sp>
       <p:sp>
         <p:nvSpPr>
-          <p:cNvPr id="11" name="Text 9"/>
-          <p:cNvSpPr/>
-          <p:nvPr/>
-        </p:nvSpPr>
-        <p:spPr>
-          <a:xfrm>
-            <a:off x="731520" y="4709160"/>
-            <a:ext cx="10698480" cy="914400"/>
+          <p:cNvPr id="9" name="Text 7"/>
+          <p:cNvSpPr/>
+          <p:nvPr/>
+        </p:nvSpPr>
+        <p:spPr>
+          <a:xfrm>
+            <a:off x="6583680" y="1600200"/>
+            <a:ext cx="4846320" cy="457200"/>
           </a:xfrm>
           <a:prstGeom prst="rect">
             <a:avLst/>
@@ -7534,13 +8042,13 @@
             <a:r>
               <a:rPr lang="en-US" sz="1400" b="1" dirty="0">
                 <a:solidFill>
-                  <a:srgbClr val="0F6E56"/>
-                </a:solidFill>
-                <a:latin typeface="Calibri" pitchFamily="34" charset="0"/>
-                <a:ea typeface="Calibri" pitchFamily="34" charset="-122"/>
-                <a:cs typeface="Calibri" pitchFamily="34" charset="-120"/>
-              </a:rPr>
-              <a:t>Both gaps trace to one understood root cause. The full pipeline is deterministic and reproducible — a reviewer can clone the repo and reproduce every number reported.</a:t>
+                  <a:srgbClr val="2F5496"/>
+                </a:solidFill>
+                <a:latin typeface="Calibri" pitchFamily="34" charset="0"/>
+                <a:ea typeface="Calibri" pitchFamily="34" charset="-122"/>
+                <a:cs typeface="Calibri" pitchFamily="34" charset="-120"/>
+              </a:rPr>
+              <a:t>VS-204 cutoff — resolved</a:t>
             </a:r>
             <a:endParaRPr lang="en-US" sz="1400" dirty="0"/>
           </a:p>
@@ -7548,7 +8056,290 @@
       </p:sp>
       <p:sp>
         <p:nvSpPr>
-          <p:cNvPr id="12" name="Text 10"/>
+          <p:cNvPr id="10" name="Text 8"/>
+          <p:cNvSpPr/>
+          <p:nvPr/>
+        </p:nvSpPr>
+        <p:spPr>
+          <a:xfrm>
+            <a:off x="6583680" y="2057400"/>
+            <a:ext cx="4892040" cy="1097280"/>
+          </a:xfrm>
+          <a:prstGeom prst="rect">
+            <a:avLst/>
+          </a:prstGeom>
+          <a:noFill/>
+          <a:ln/>
+        </p:spPr>
+        <p:txBody>
+          <a:bodyPr wrap="square" rtlCol="0" anchor="ctr"/>
+          <a:lstStyle/>
+          <a:p>
+            <a:pPr indent="0" marL="0">
+              <a:buNone/>
+            </a:pPr>
+            <a:r>
+              <a:rPr lang="en-US" sz="1150" dirty="0">
+                <a:solidFill>
+                  <a:srgbClr val="1A1A1A"/>
+                </a:solidFill>
+                <a:latin typeface="Calibri" pitchFamily="34" charset="0"/>
+                <a:ea typeface="Calibri" pitchFamily="34" charset="-122"/>
+                <a:cs typeface="Calibri" pitchFamily="34" charset="-120"/>
+              </a:rPr>
+              <a:t>Scanned/clean duplicate documents were each consuming separate ranking slots. Deduplicating them freed the slot needed for the full chain.</a:t>
+            </a:r>
+            <a:endParaRPr lang="en-US" sz="1150" dirty="0"/>
+          </a:p>
+        </p:txBody>
+      </p:sp>
+      <p:sp>
+        <p:nvSpPr>
+          <p:cNvPr id="11" name="Shape 9"/>
+          <p:cNvSpPr/>
+          <p:nvPr/>
+        </p:nvSpPr>
+        <p:spPr>
+          <a:xfrm>
+            <a:off x="457200" y="3429000"/>
+            <a:ext cx="5440680" cy="1783080"/>
+          </a:xfrm>
+          <a:prstGeom prst="roundRect">
+            <a:avLst>
+              <a:gd name="adj" fmla="val 4103"/>
+            </a:avLst>
+          </a:prstGeom>
+          <a:solidFill>
+            <a:srgbClr val="F4F6F9"/>
+          </a:solidFill>
+          <a:ln/>
+        </p:spPr>
+      </p:sp>
+      <p:sp>
+        <p:nvSpPr>
+          <p:cNvPr id="12" name="Shape 10"/>
+          <p:cNvSpPr/>
+          <p:nvPr/>
+        </p:nvSpPr>
+        <p:spPr>
+          <a:xfrm>
+            <a:off x="640080" y="3611880"/>
+            <a:ext cx="109728" cy="1417320"/>
+          </a:xfrm>
+          <a:prstGeom prst="roundRect">
+            <a:avLst>
+              <a:gd name="adj" fmla="val 41667"/>
+            </a:avLst>
+          </a:prstGeom>
+          <a:solidFill>
+            <a:srgbClr val="993C1D"/>
+          </a:solidFill>
+          <a:ln/>
+        </p:spPr>
+      </p:sp>
+      <p:sp>
+        <p:nvSpPr>
+          <p:cNvPr id="13" name="Text 11"/>
+          <p:cNvSpPr/>
+          <p:nvPr/>
+        </p:nvSpPr>
+        <p:spPr>
+          <a:xfrm>
+            <a:off x="868680" y="3566160"/>
+            <a:ext cx="4846320" cy="457200"/>
+          </a:xfrm>
+          <a:prstGeom prst="rect">
+            <a:avLst/>
+          </a:prstGeom>
+          <a:noFill/>
+          <a:ln/>
+        </p:spPr>
+        <p:txBody>
+          <a:bodyPr wrap="square" rtlCol="0" anchor="ctr"/>
+          <a:lstStyle/>
+          <a:p>
+            <a:pPr indent="0" marL="0">
+              <a:buNone/>
+            </a:pPr>
+            <a:r>
+              <a:rPr lang="en-US" sz="1400" b="1" dirty="0">
+                <a:solidFill>
+                  <a:srgbClr val="993C1D"/>
+                </a:solidFill>
+                <a:latin typeface="Calibri" pitchFamily="34" charset="0"/>
+                <a:ea typeface="Calibri" pitchFamily="34" charset="-122"/>
+                <a:cs typeface="Calibri" pitchFamily="34" charset="-120"/>
+              </a:rPr>
+              <a:t>Q02 hop-tier tie-flooding — still open</a:t>
+            </a:r>
+            <a:endParaRPr lang="en-US" sz="1400" dirty="0"/>
+          </a:p>
+        </p:txBody>
+      </p:sp>
+      <p:sp>
+        <p:nvSpPr>
+          <p:cNvPr id="14" name="Text 12"/>
+          <p:cNvSpPr/>
+          <p:nvPr/>
+        </p:nvSpPr>
+        <p:spPr>
+          <a:xfrm>
+            <a:off x="868680" y="4023360"/>
+            <a:ext cx="4892040" cy="1097280"/>
+          </a:xfrm>
+          <a:prstGeom prst="rect">
+            <a:avLst/>
+          </a:prstGeom>
+          <a:noFill/>
+          <a:ln/>
+        </p:spPr>
+        <p:txBody>
+          <a:bodyPr wrap="square" rtlCol="0" anchor="ctr"/>
+          <a:lstStyle/>
+          <a:p>
+            <a:pPr indent="0" marL="0">
+              <a:buNone/>
+            </a:pPr>
+            <a:r>
+              <a:rPr lang="en-US" sz="1150" dirty="0">
+                <a:solidFill>
+                  <a:srgbClr val="1A1A1A"/>
+                </a:solidFill>
+                <a:latin typeface="Calibri" pitchFamily="34" charset="0"/>
+                <a:ea typeface="Calibri" pitchFamily="34" charset="-122"/>
+                <a:cs typeface="Calibri" pitchFamily="34" charset="-120"/>
+              </a:rPr>
+              <a:t>A structurally different ranking ceiling. Two fixes attempted and precisely diagnosed; neither crosses the tie-flooded tier.</a:t>
+            </a:r>
+            <a:endParaRPr lang="en-US" sz="1150" dirty="0"/>
+          </a:p>
+        </p:txBody>
+      </p:sp>
+      <p:sp>
+        <p:nvSpPr>
+          <p:cNvPr id="15" name="Shape 13"/>
+          <p:cNvSpPr/>
+          <p:nvPr/>
+        </p:nvSpPr>
+        <p:spPr>
+          <a:xfrm>
+            <a:off x="6172200" y="3429000"/>
+            <a:ext cx="5440680" cy="1783080"/>
+          </a:xfrm>
+          <a:prstGeom prst="roundRect">
+            <a:avLst>
+              <a:gd name="adj" fmla="val 4103"/>
+            </a:avLst>
+          </a:prstGeom>
+          <a:solidFill>
+            <a:srgbClr val="F4F6F9"/>
+          </a:solidFill>
+          <a:ln/>
+        </p:spPr>
+      </p:sp>
+      <p:sp>
+        <p:nvSpPr>
+          <p:cNvPr id="16" name="Shape 14"/>
+          <p:cNvSpPr/>
+          <p:nvPr/>
+        </p:nvSpPr>
+        <p:spPr>
+          <a:xfrm>
+            <a:off x="6355080" y="3611880"/>
+            <a:ext cx="109728" cy="1417320"/>
+          </a:xfrm>
+          <a:prstGeom prst="roundRect">
+            <a:avLst>
+              <a:gd name="adj" fmla="val 41667"/>
+            </a:avLst>
+          </a:prstGeom>
+          <a:solidFill>
+            <a:srgbClr val="B8860B"/>
+          </a:solidFill>
+          <a:ln/>
+        </p:spPr>
+      </p:sp>
+      <p:sp>
+        <p:nvSpPr>
+          <p:cNvPr id="17" name="Text 15"/>
+          <p:cNvSpPr/>
+          <p:nvPr/>
+        </p:nvSpPr>
+        <p:spPr>
+          <a:xfrm>
+            <a:off x="6583680" y="3566160"/>
+            <a:ext cx="4846320" cy="457200"/>
+          </a:xfrm>
+          <a:prstGeom prst="rect">
+            <a:avLst/>
+          </a:prstGeom>
+          <a:noFill/>
+          <a:ln/>
+        </p:spPr>
+        <p:txBody>
+          <a:bodyPr wrap="square" rtlCol="0" anchor="ctr"/>
+          <a:lstStyle/>
+          <a:p>
+            <a:pPr indent="0" marL="0">
+              <a:buNone/>
+            </a:pPr>
+            <a:r>
+              <a:rPr lang="en-US" sz="1400" b="1" dirty="0">
+                <a:solidFill>
+                  <a:srgbClr val="B8860B"/>
+                </a:solidFill>
+                <a:latin typeface="Calibri" pitchFamily="34" charset="0"/>
+                <a:ea typeface="Calibri" pitchFamily="34" charset="-122"/>
+                <a:cs typeface="Calibri" pitchFamily="34" charset="-120"/>
+              </a:rPr>
+              <a:t>26 automated tests + CI</a:t>
+            </a:r>
+            <a:endParaRPr lang="en-US" sz="1400" dirty="0"/>
+          </a:p>
+        </p:txBody>
+      </p:sp>
+      <p:sp>
+        <p:nvSpPr>
+          <p:cNvPr id="18" name="Text 16"/>
+          <p:cNvSpPr/>
+          <p:nvPr/>
+        </p:nvSpPr>
+        <p:spPr>
+          <a:xfrm>
+            <a:off x="6583680" y="4023360"/>
+            <a:ext cx="4892040" cy="1097280"/>
+          </a:xfrm>
+          <a:prstGeom prst="rect">
+            <a:avLst/>
+          </a:prstGeom>
+          <a:noFill/>
+          <a:ln/>
+        </p:spPr>
+        <p:txBody>
+          <a:bodyPr wrap="square" rtlCol="0" anchor="ctr"/>
+          <a:lstStyle/>
+          <a:p>
+            <a:pPr indent="0" marL="0">
+              <a:buNone/>
+            </a:pPr>
+            <a:r>
+              <a:rPr lang="en-US" sz="1150" dirty="0">
+                <a:solidFill>
+                  <a:srgbClr val="1A1A1A"/>
+                </a:solidFill>
+                <a:latin typeface="Calibri" pitchFamily="34" charset="0"/>
+                <a:ea typeface="Calibri" pitchFamily="34" charset="-122"/>
+                <a:cs typeface="Calibri" pitchFamily="34" charset="-120"/>
+              </a:rPr>
+              <a:t>Chunking, citations, determinism, graph invariants, eval-data consistency — running automatically on every push.</a:t>
+            </a:r>
+            <a:endParaRPr lang="en-US" sz="1150" dirty="0"/>
+          </a:p>
+        </p:txBody>
+      </p:sp>
+      <p:sp>
+        <p:nvSpPr>
+          <p:cNvPr id="19" name="Text 17"/>
           <p:cNvSpPr/>
           <p:nvPr/>
         </p:nvSpPr>
@@ -7579,7 +8370,7 @@
                 <a:ea typeface="Calibri" pitchFamily="34" charset="-122"/>
                 <a:cs typeface="Calibri" pitchFamily="34" charset="-120"/>
               </a:rPr>
-              <a:t>ET AI Hackathon 2.0  ·  Problem #8  ·  Industrial Knowledge Intelligence</a:t>
+              <a:t>ET AI Hackathon 2.0  ·  Problem #8  ·  Industrial Knowledge Intelligence (Revised)</a:t>
             </a:r>
             <a:endParaRPr lang="en-US" sz="900" dirty="0"/>
           </a:p>
@@ -7587,7 +8378,7 @@
       </p:sp>
       <p:sp>
         <p:nvSpPr>
-          <p:cNvPr id="13" name="Text 11"/>
+          <p:cNvPr id="20" name="Text 18"/>
           <p:cNvSpPr/>
           <p:nvPr/>
         </p:nvSpPr>

</xml_diff>